<commit_message>
Rework success measures table to map to the four intended outcomes
Co-Authored-By: Claude Sonnet 5.5 <noreply@anthropic.com>
Claude-Session: https://claude.ai/code/session_0162u49WoZY78L9tYzoPfiKK
</commit_message>
<xml_diff>
--- a/deliverables/Pilot_Success_Measures_Table.pptx
+++ b/deliverables/Pilot_Success_Measures_Table.pptx
@@ -502,7 +502,7 @@
           <a:p>
             <a:r>
               <a:rPr lang="en-US" dirty="0"/>
-              <a:t>Targets set at 80% to match the Pod's MVS Roll-out Plan effectiveness measures. Pilot group is about 21 users, so 80% is roughly 17 participants. The 66% baseline comes from the Gentari-wide talent survey (115 respondents).</a:t>
+              <a:t>Rows map to the four intended outcomes: Effectiveness = outcome 1 (understanding), Quality = outcome 3 (ruler validated), Adoption = outcome 2 (gaps identified and translated into development actions), Scalability = outcome 4 (repeatable approach). Percentage targets set at 80% to match the Pod's MVS Roll-out Plan. Pilot group is about 21 users, so 80% is roughly 17 participants. The 66% baseline comes from the Gentari-wide talent survey (115 respondents).</a:t>
             </a:r>
             <a:endParaRPr lang="en-US" dirty="0"/>
           </a:p>
@@ -1315,7 +1315,7 @@
                   </a:tcPr>
                 </a:tc>
               </a:tr>
-              <a:tr h="1188720">
+              <a:tr h="1005840">
                 <a:tc>
                   <a:txBody>
                     <a:bodyPr/>
@@ -1405,7 +1405,7 @@
                           <a:ea typeface="Arial" pitchFamily="34" charset="-122"/>
                           <a:cs typeface="Arial" pitchFamily="34" charset="-120"/>
                         </a:rPr>
-                        <a:t>% of participants who report better understanding of capability expectations and development pathways</a:t>
+                        <a:t>% of participating employees and managers who report a clear understanding of capability expectations</a:t>
                       </a:r>
                       <a:endParaRPr lang="en-US" sz="1200" dirty="0">
                         <a:latin typeface="Arial" charset="0"/>
@@ -1474,7 +1474,7 @@
                           <a:ea typeface="Arial" pitchFamily="34" charset="-122"/>
                           <a:cs typeface="Arial" pitchFamily="34" charset="-120"/>
                         </a:rPr>
-                        <a:t>Pre-pilot pulse and structured assessment of participant understanding</a:t>
+                        <a:t>Pre-pilot pulse of participant and manager understanding</a:t>
                       </a:r>
                       <a:endParaRPr lang="en-US" sz="1200" dirty="0">
                         <a:latin typeface="Arial" charset="0"/>
@@ -1579,7 +1579,7 @@
                           <a:ea typeface="Arial" pitchFamily="34" charset="-122"/>
                           <a:cs typeface="Arial" pitchFamily="34" charset="-120"/>
                         </a:rPr>
-                        <a:t> of participants report increased understanding vs. baseline, each with at least 1 development pathway identified</a:t>
+                        <a:t> of participants and managers report clear understanding vs. baseline</a:t>
                       </a:r>
                       <a:endParaRPr lang="en-US" sz="1200" dirty="0">
                         <a:latin typeface="Arial" charset="0"/>
@@ -1673,7 +1673,7 @@
                           <a:ea typeface="Arial" pitchFamily="34" charset="-122"/>
                           <a:cs typeface="Arial" pitchFamily="34" charset="-120"/>
                         </a:rPr>
-                        <a:t>Structured participant feedback</a:t>
+                        <a:t>Participant and manager feedback</a:t>
                       </a:r>
                       <a:endParaRPr lang="en-US" sz="1200" dirty="0">
                         <a:latin typeface="Arial" charset="0"/>
@@ -1816,7 +1816,7 @@
                   </a:tcPr>
                 </a:tc>
               </a:tr>
-              <a:tr h="1188720">
+              <a:tr h="1143000">
                 <a:tc>
                   <a:txBody>
                     <a:bodyPr/>
@@ -1906,7 +1906,7 @@
                           <a:ea typeface="Arial" pitchFamily="34" charset="-122"/>
                           <a:cs typeface="Arial" pitchFamily="34" charset="-120"/>
                         </a:rPr>
-                        <a:t>% of participants and managers who rate the customised Electrical Competency Ruler as clear, relevant and fit for purpose</a:t>
+                        <a:t>Customised Gentari Electrical Competency Ruler validated for the Electrical discipline (% favourable rating: clear, relevant, fit for purpose)</a:t>
                       </a:r>
                       <a:endParaRPr lang="en-US" sz="1200" dirty="0">
                         <a:latin typeface="Arial" charset="0"/>
@@ -1975,7 +1975,7 @@
                           <a:ea typeface="Arial" pitchFamily="34" charset="-122"/>
                           <a:cs typeface="Arial" pitchFamily="34" charset="-120"/>
                         </a:rPr>
-                        <a:t>No Gentari-specific validated Electrical Competency Ruler currently in use</a:t>
+                        <a:t>No Gentari-specific validated Electrical Competency Ruler in use</a:t>
                       </a:r>
                       <a:endParaRPr lang="en-US" sz="1200" dirty="0">
                         <a:latin typeface="Arial" charset="0"/>
@@ -2044,7 +2044,7 @@
                           <a:ea typeface="Arial" pitchFamily="34" charset="-122"/>
                           <a:cs typeface="Arial" pitchFamily="34" charset="-120"/>
                         </a:rPr>
-                        <a:t>At least </a:t>
+                        <a:t>Ruler validated by technical specialists and PETRONAS custodian; at least </a:t>
                       </a:r>
                       <a:pPr algn="l" marL="152400" indent="-152400">
                         <a:spcAft>
@@ -2080,7 +2080,7 @@
                           <a:ea typeface="Arial" pitchFamily="34" charset="-122"/>
                           <a:cs typeface="Arial" pitchFamily="34" charset="-120"/>
                         </a:rPr>
-                        <a:t> favourable response from pilot participants, managers and reviewers</a:t>
+                        <a:t> favourable response</a:t>
                       </a:r>
                       <a:endParaRPr lang="en-US" sz="1200" dirty="0">
                         <a:latin typeface="Arial" charset="0"/>
@@ -2174,7 +2174,7 @@
                           <a:ea typeface="Arial" pitchFamily="34" charset="-122"/>
                           <a:cs typeface="Arial" pitchFamily="34" charset="-120"/>
                         </a:rPr>
-                        <a:t>Pulse survey</a:t>
+                        <a:t>Specialist and custodian sign-off</a:t>
                       </a:r>
                       <a:endParaRPr lang="en-US" sz="1200" dirty="0">
                         <a:latin typeface="Arial" charset="0"/>
@@ -2317,7 +2317,7 @@
                   </a:tcPr>
                 </a:tc>
               </a:tr>
-              <a:tr h="1280160">
+              <a:tr h="1234440">
                 <a:tc>
                   <a:txBody>
                     <a:bodyPr/>
@@ -2407,7 +2407,7 @@
                           <a:ea typeface="Arial" pitchFamily="34" charset="-122"/>
                           <a:cs typeface="Arial" pitchFamily="34" charset="-120"/>
                         </a:rPr>
-                        <a:t>% of assessed participants with agreed development actions, reviewed and actioned through their Individual Development Plan (IDP)</a:t>
+                        <a:t>% of assessed participants whose priority capability gaps are identified and translated into agreed development actions in their IDP</a:t>
                       </a:r>
                       <a:endParaRPr lang="en-US" sz="1200" dirty="0">
                         <a:latin typeface="Arial" charset="0"/>
@@ -2606,7 +2606,7 @@
                           <a:ea typeface="Arial" pitchFamily="34" charset="-122"/>
                           <a:cs typeface="Arial" pitchFamily="34" charset="-120"/>
                         </a:rPr>
-                        <a:t> of assessed participants have agreed development actions</a:t>
+                        <a:t> of assessed participants have agreed development actions in their IDP</a:t>
                       </a:r>
                       <a:endParaRPr lang="en-US" sz="1200" dirty="0">
                         <a:latin typeface="Arial" charset="0"/>
@@ -2777,6 +2777,446 @@
                         <a:cs typeface="Arial" charset="0"/>
                       </a:endParaRPr>
                     </a:p>
+                    <a:p>
+                      <a:pPr algn="l" marL="152400" indent="-152400">
+                        <a:spcAft>
+                          <a:spcPts val="300"/>
+                        </a:spcAft>
+                        <a:buSzPct val="100000"/>
+                        <a:buChar char="•"/>
+                      </a:pPr>
+                      <a:r>
+                        <a:rPr lang="en-US" sz="1100" dirty="0">
+                          <a:solidFill>
+                            <a:srgbClr val="262626"/>
+                          </a:solidFill>
+                          <a:latin typeface="Arial" pitchFamily="34" charset="0"/>
+                          <a:ea typeface="Arial" pitchFamily="34" charset="-122"/>
+                          <a:cs typeface="Arial" pitchFamily="34" charset="-120"/>
+                        </a:rPr>
+                        <a:t>At pilot review</a:t>
+                      </a:r>
+                      <a:endParaRPr lang="en-US" sz="1200" dirty="0">
+                        <a:latin typeface="Arial" charset="0"/>
+                        <a:ea typeface="Arial" charset="0"/>
+                        <a:cs typeface="Arial" charset="0"/>
+                      </a:endParaRPr>
+                    </a:p>
+                  </a:txBody>
+                  <a:tcPr marL="76200" marR="76200" marT="50800" marB="50800" anchor="ctr">
+                    <a:lnL w="9525" cap="flat" cmpd="sng" algn="ctr">
+                      <a:solidFill>
+                        <a:srgbClr val="BFBFBF"/>
+                      </a:solidFill>
+                      <a:prstDash val="solid"/>
+                      <a:round/>
+                      <a:headEnd type="none" w="med" len="med"/>
+                      <a:tailEnd type="none" w="med" len="med"/>
+                    </a:lnL>
+                    <a:lnR w="9525" cap="flat" cmpd="sng" algn="ctr">
+                      <a:solidFill>
+                        <a:srgbClr val="BFBFBF"/>
+                      </a:solidFill>
+                      <a:prstDash val="solid"/>
+                      <a:round/>
+                      <a:headEnd type="none" w="med" len="med"/>
+                      <a:tailEnd type="none" w="med" len="med"/>
+                    </a:lnR>
+                    <a:lnT w="9525" cap="flat" cmpd="sng" algn="ctr">
+                      <a:solidFill>
+                        <a:srgbClr val="BFBFBF"/>
+                      </a:solidFill>
+                      <a:prstDash val="solid"/>
+                      <a:round/>
+                      <a:headEnd type="none" w="med" len="med"/>
+                      <a:tailEnd type="none" w="med" len="med"/>
+                    </a:lnT>
+                    <a:lnB w="9525" cap="flat" cmpd="sng" algn="ctr">
+                      <a:solidFill>
+                        <a:srgbClr val="BFBFBF"/>
+                      </a:solidFill>
+                      <a:prstDash val="solid"/>
+                      <a:round/>
+                      <a:headEnd type="none" w="med" len="med"/>
+                      <a:tailEnd type="none" w="med" len="med"/>
+                    </a:lnB>
+                  </a:tcPr>
+                </a:tc>
+              </a:tr>
+              <a:tr h="1005840">
+                <a:tc>
+                  <a:txBody>
+                    <a:bodyPr/>
+                    <a:lstStyle/>
+                    <a:p>
+                      <a:pPr algn="ctr" indent="0" marL="0">
+                        <a:buNone/>
+                      </a:pPr>
+                      <a:r>
+                        <a:rPr lang="en-US" sz="1200" b="1" dirty="0">
+                          <a:solidFill>
+                            <a:srgbClr val="262626"/>
+                          </a:solidFill>
+                          <a:latin typeface="Arial" pitchFamily="34" charset="0"/>
+                          <a:ea typeface="Arial" pitchFamily="34" charset="-122"/>
+                          <a:cs typeface="Arial" pitchFamily="34" charset="-120"/>
+                        </a:rPr>
+                        <a:t>Scalability</a:t>
+                      </a:r>
+                      <a:endParaRPr lang="en-US" sz="1200" dirty="0">
+                        <a:latin typeface="Arial" charset="0"/>
+                        <a:ea typeface="Arial" charset="0"/>
+                        <a:cs typeface="Arial" charset="0"/>
+                      </a:endParaRPr>
+                    </a:p>
+                  </a:txBody>
+                  <a:tcPr marL="91440" marR="91440" marT="45720" marB="45720" anchor="ctr">
+                    <a:lnL w="9525" cap="flat" cmpd="sng" algn="ctr">
+                      <a:solidFill>
+                        <a:srgbClr val="BFBFBF"/>
+                      </a:solidFill>
+                      <a:prstDash val="solid"/>
+                      <a:round/>
+                      <a:headEnd type="none" w="med" len="med"/>
+                      <a:tailEnd type="none" w="med" len="med"/>
+                    </a:lnL>
+                    <a:lnR w="9525" cap="flat" cmpd="sng" algn="ctr">
+                      <a:solidFill>
+                        <a:srgbClr val="BFBFBF"/>
+                      </a:solidFill>
+                      <a:prstDash val="solid"/>
+                      <a:round/>
+                      <a:headEnd type="none" w="med" len="med"/>
+                      <a:tailEnd type="none" w="med" len="med"/>
+                    </a:lnR>
+                    <a:lnT w="9525" cap="flat" cmpd="sng" algn="ctr">
+                      <a:solidFill>
+                        <a:srgbClr val="BFBFBF"/>
+                      </a:solidFill>
+                      <a:prstDash val="solid"/>
+                      <a:round/>
+                      <a:headEnd type="none" w="med" len="med"/>
+                      <a:tailEnd type="none" w="med" len="med"/>
+                    </a:lnT>
+                    <a:lnB w="9525" cap="flat" cmpd="sng" algn="ctr">
+                      <a:solidFill>
+                        <a:srgbClr val="BFBFBF"/>
+                      </a:solidFill>
+                      <a:prstDash val="solid"/>
+                      <a:round/>
+                      <a:headEnd type="none" w="med" len="med"/>
+                      <a:tailEnd type="none" w="med" len="med"/>
+                    </a:lnB>
+                    <a:solidFill>
+                      <a:srgbClr val="F2F2F2"/>
+                    </a:solidFill>
+                  </a:tcPr>
+                </a:tc>
+                <a:tc>
+                  <a:txBody>
+                    <a:bodyPr/>
+                    <a:lstStyle/>
+                    <a:p>
+                      <a:pPr algn="l" marL="152400" indent="-152400">
+                        <a:spcAft>
+                          <a:spcPts val="300"/>
+                        </a:spcAft>
+                        <a:buSzPct val="100000"/>
+                        <a:buChar char="•"/>
+                      </a:pPr>
+                      <a:r>
+                        <a:rPr lang="en-US" sz="1100" dirty="0">
+                          <a:solidFill>
+                            <a:srgbClr val="262626"/>
+                          </a:solidFill>
+                          <a:latin typeface="Arial" pitchFamily="34" charset="0"/>
+                          <a:ea typeface="Arial" pitchFamily="34" charset="-122"/>
+                          <a:cs typeface="Arial" pitchFamily="34" charset="-120"/>
+                        </a:rPr>
+                        <a:t>Repeatable capability-ruler approach documented for extension to other technical disciplines</a:t>
+                      </a:r>
+                      <a:endParaRPr lang="en-US" sz="1200" dirty="0">
+                        <a:latin typeface="Arial" charset="0"/>
+                        <a:ea typeface="Arial" charset="0"/>
+                        <a:cs typeface="Arial" charset="0"/>
+                      </a:endParaRPr>
+                    </a:p>
+                  </a:txBody>
+                  <a:tcPr marL="76200" marR="76200" marT="50800" marB="50800" anchor="ctr">
+                    <a:lnL w="9525" cap="flat" cmpd="sng" algn="ctr">
+                      <a:solidFill>
+                        <a:srgbClr val="BFBFBF"/>
+                      </a:solidFill>
+                      <a:prstDash val="solid"/>
+                      <a:round/>
+                      <a:headEnd type="none" w="med" len="med"/>
+                      <a:tailEnd type="none" w="med" len="med"/>
+                    </a:lnL>
+                    <a:lnR w="9525" cap="flat" cmpd="sng" algn="ctr">
+                      <a:solidFill>
+                        <a:srgbClr val="BFBFBF"/>
+                      </a:solidFill>
+                      <a:prstDash val="solid"/>
+                      <a:round/>
+                      <a:headEnd type="none" w="med" len="med"/>
+                      <a:tailEnd type="none" w="med" len="med"/>
+                    </a:lnR>
+                    <a:lnT w="9525" cap="flat" cmpd="sng" algn="ctr">
+                      <a:solidFill>
+                        <a:srgbClr val="BFBFBF"/>
+                      </a:solidFill>
+                      <a:prstDash val="solid"/>
+                      <a:round/>
+                      <a:headEnd type="none" w="med" len="med"/>
+                      <a:tailEnd type="none" w="med" len="med"/>
+                    </a:lnT>
+                    <a:lnB w="9525" cap="flat" cmpd="sng" algn="ctr">
+                      <a:solidFill>
+                        <a:srgbClr val="BFBFBF"/>
+                      </a:solidFill>
+                      <a:prstDash val="solid"/>
+                      <a:round/>
+                      <a:headEnd type="none" w="med" len="med"/>
+                      <a:tailEnd type="none" w="med" len="med"/>
+                    </a:lnB>
+                  </a:tcPr>
+                </a:tc>
+                <a:tc>
+                  <a:txBody>
+                    <a:bodyPr/>
+                    <a:lstStyle/>
+                    <a:p>
+                      <a:pPr algn="l" marL="152400" indent="-152400">
+                        <a:spcAft>
+                          <a:spcPts val="300"/>
+                        </a:spcAft>
+                        <a:buSzPct val="100000"/>
+                        <a:buChar char="•"/>
+                      </a:pPr>
+                      <a:r>
+                        <a:rPr lang="en-US" sz="1100" dirty="0">
+                          <a:solidFill>
+                            <a:srgbClr val="262626"/>
+                          </a:solidFill>
+                          <a:latin typeface="Arial" pitchFamily="34" charset="0"/>
+                          <a:ea typeface="Arial" pitchFamily="34" charset="-122"/>
+                          <a:cs typeface="Arial" pitchFamily="34" charset="-120"/>
+                        </a:rPr>
+                        <a:t>No repeatable capability-ruler approach in place</a:t>
+                      </a:r>
+                      <a:endParaRPr lang="en-US" sz="1200" dirty="0">
+                        <a:latin typeface="Arial" charset="0"/>
+                        <a:ea typeface="Arial" charset="0"/>
+                        <a:cs typeface="Arial" charset="0"/>
+                      </a:endParaRPr>
+                    </a:p>
+                  </a:txBody>
+                  <a:tcPr marL="76200" marR="76200" marT="50800" marB="50800" anchor="ctr">
+                    <a:lnL w="9525" cap="flat" cmpd="sng" algn="ctr">
+                      <a:solidFill>
+                        <a:srgbClr val="BFBFBF"/>
+                      </a:solidFill>
+                      <a:prstDash val="solid"/>
+                      <a:round/>
+                      <a:headEnd type="none" w="med" len="med"/>
+                      <a:tailEnd type="none" w="med" len="med"/>
+                    </a:lnL>
+                    <a:lnR w="9525" cap="flat" cmpd="sng" algn="ctr">
+                      <a:solidFill>
+                        <a:srgbClr val="BFBFBF"/>
+                      </a:solidFill>
+                      <a:prstDash val="solid"/>
+                      <a:round/>
+                      <a:headEnd type="none" w="med" len="med"/>
+                      <a:tailEnd type="none" w="med" len="med"/>
+                    </a:lnR>
+                    <a:lnT w="9525" cap="flat" cmpd="sng" algn="ctr">
+                      <a:solidFill>
+                        <a:srgbClr val="BFBFBF"/>
+                      </a:solidFill>
+                      <a:prstDash val="solid"/>
+                      <a:round/>
+                      <a:headEnd type="none" w="med" len="med"/>
+                      <a:tailEnd type="none" w="med" len="med"/>
+                    </a:lnT>
+                    <a:lnB w="9525" cap="flat" cmpd="sng" algn="ctr">
+                      <a:solidFill>
+                        <a:srgbClr val="BFBFBF"/>
+                      </a:solidFill>
+                      <a:prstDash val="solid"/>
+                      <a:round/>
+                      <a:headEnd type="none" w="med" len="med"/>
+                      <a:tailEnd type="none" w="med" len="med"/>
+                    </a:lnB>
+                  </a:tcPr>
+                </a:tc>
+                <a:tc>
+                  <a:txBody>
+                    <a:bodyPr/>
+                    <a:lstStyle/>
+                    <a:p>
+                      <a:pPr algn="l" marL="152400" indent="-152400">
+                        <a:spcAft>
+                          <a:spcPts val="300"/>
+                        </a:spcAft>
+                        <a:buSzPct val="100000"/>
+                        <a:buChar char="•"/>
+                      </a:pPr>
+                      <a:r>
+                        <a:rPr lang="en-US" sz="1100" dirty="0">
+                          <a:solidFill>
+                            <a:srgbClr val="262626"/>
+                          </a:solidFill>
+                          <a:latin typeface="Arial" pitchFamily="34" charset="0"/>
+                          <a:ea typeface="Arial" pitchFamily="34" charset="-122"/>
+                          <a:cs typeface="Arial" pitchFamily="34" charset="-120"/>
+                        </a:rPr>
+                        <a:t>Approach documented (ruler, assessment, development linkage) with extension recommendation in the pilot report</a:t>
+                      </a:r>
+                      <a:endParaRPr lang="en-US" sz="1200" dirty="0">
+                        <a:latin typeface="Arial" charset="0"/>
+                        <a:ea typeface="Arial" charset="0"/>
+                        <a:cs typeface="Arial" charset="0"/>
+                      </a:endParaRPr>
+                    </a:p>
+                  </a:txBody>
+                  <a:tcPr marL="76200" marR="76200" marT="50800" marB="50800" anchor="ctr">
+                    <a:lnL w="9525" cap="flat" cmpd="sng" algn="ctr">
+                      <a:solidFill>
+                        <a:srgbClr val="BFBFBF"/>
+                      </a:solidFill>
+                      <a:prstDash val="solid"/>
+                      <a:round/>
+                      <a:headEnd type="none" w="med" len="med"/>
+                      <a:tailEnd type="none" w="med" len="med"/>
+                    </a:lnL>
+                    <a:lnR w="9525" cap="flat" cmpd="sng" algn="ctr">
+                      <a:solidFill>
+                        <a:srgbClr val="BFBFBF"/>
+                      </a:solidFill>
+                      <a:prstDash val="solid"/>
+                      <a:round/>
+                      <a:headEnd type="none" w="med" len="med"/>
+                      <a:tailEnd type="none" w="med" len="med"/>
+                    </a:lnR>
+                    <a:lnT w="9525" cap="flat" cmpd="sng" algn="ctr">
+                      <a:solidFill>
+                        <a:srgbClr val="BFBFBF"/>
+                      </a:solidFill>
+                      <a:prstDash val="solid"/>
+                      <a:round/>
+                      <a:headEnd type="none" w="med" len="med"/>
+                      <a:tailEnd type="none" w="med" len="med"/>
+                    </a:lnT>
+                    <a:lnB w="9525" cap="flat" cmpd="sng" algn="ctr">
+                      <a:solidFill>
+                        <a:srgbClr val="BFBFBF"/>
+                      </a:solidFill>
+                      <a:prstDash val="solid"/>
+                      <a:round/>
+                      <a:headEnd type="none" w="med" len="med"/>
+                      <a:tailEnd type="none" w="med" len="med"/>
+                    </a:lnB>
+                  </a:tcPr>
+                </a:tc>
+                <a:tc>
+                  <a:txBody>
+                    <a:bodyPr/>
+                    <a:lstStyle/>
+                    <a:p>
+                      <a:pPr algn="l" marL="152400" indent="-152400">
+                        <a:spcAft>
+                          <a:spcPts val="300"/>
+                        </a:spcAft>
+                        <a:buSzPct val="100000"/>
+                        <a:buChar char="•"/>
+                      </a:pPr>
+                      <a:r>
+                        <a:rPr lang="en-US" sz="1100" dirty="0">
+                          <a:solidFill>
+                            <a:srgbClr val="262626"/>
+                          </a:solidFill>
+                          <a:latin typeface="Arial" pitchFamily="34" charset="0"/>
+                          <a:ea typeface="Arial" pitchFamily="34" charset="-122"/>
+                          <a:cs typeface="Arial" pitchFamily="34" charset="-120"/>
+                        </a:rPr>
+                        <a:t>Pilot report</a:t>
+                      </a:r>
+                      <a:endParaRPr lang="en-US" sz="1200" dirty="0">
+                        <a:latin typeface="Arial" charset="0"/>
+                        <a:ea typeface="Arial" charset="0"/>
+                        <a:cs typeface="Arial" charset="0"/>
+                      </a:endParaRPr>
+                    </a:p>
+                    <a:p>
+                      <a:pPr algn="l" marL="152400" indent="-152400">
+                        <a:spcAft>
+                          <a:spcPts val="300"/>
+                        </a:spcAft>
+                        <a:buSzPct val="100000"/>
+                        <a:buChar char="•"/>
+                      </a:pPr>
+                      <a:r>
+                        <a:rPr lang="en-US" sz="1100" dirty="0">
+                          <a:solidFill>
+                            <a:srgbClr val="262626"/>
+                          </a:solidFill>
+                          <a:latin typeface="Arial" pitchFamily="34" charset="0"/>
+                          <a:ea typeface="Arial" pitchFamily="34" charset="-122"/>
+                          <a:cs typeface="Arial" pitchFamily="34" charset="-120"/>
+                        </a:rPr>
+                        <a:t>Lessons learned</a:t>
+                      </a:r>
+                      <a:endParaRPr lang="en-US" sz="1200" dirty="0">
+                        <a:latin typeface="Arial" charset="0"/>
+                        <a:ea typeface="Arial" charset="0"/>
+                        <a:cs typeface="Arial" charset="0"/>
+                      </a:endParaRPr>
+                    </a:p>
+                  </a:txBody>
+                  <a:tcPr marL="76200" marR="76200" marT="50800" marB="50800" anchor="ctr">
+                    <a:lnL w="9525" cap="flat" cmpd="sng" algn="ctr">
+                      <a:solidFill>
+                        <a:srgbClr val="BFBFBF"/>
+                      </a:solidFill>
+                      <a:prstDash val="solid"/>
+                      <a:round/>
+                      <a:headEnd type="none" w="med" len="med"/>
+                      <a:tailEnd type="none" w="med" len="med"/>
+                    </a:lnL>
+                    <a:lnR w="9525" cap="flat" cmpd="sng" algn="ctr">
+                      <a:solidFill>
+                        <a:srgbClr val="BFBFBF"/>
+                      </a:solidFill>
+                      <a:prstDash val="solid"/>
+                      <a:round/>
+                      <a:headEnd type="none" w="med" len="med"/>
+                      <a:tailEnd type="none" w="med" len="med"/>
+                    </a:lnR>
+                    <a:lnT w="9525" cap="flat" cmpd="sng" algn="ctr">
+                      <a:solidFill>
+                        <a:srgbClr val="BFBFBF"/>
+                      </a:solidFill>
+                      <a:prstDash val="solid"/>
+                      <a:round/>
+                      <a:headEnd type="none" w="med" len="med"/>
+                      <a:tailEnd type="none" w="med" len="med"/>
+                    </a:lnT>
+                    <a:lnB w="9525" cap="flat" cmpd="sng" algn="ctr">
+                      <a:solidFill>
+                        <a:srgbClr val="BFBFBF"/>
+                      </a:solidFill>
+                      <a:prstDash val="solid"/>
+                      <a:round/>
+                      <a:headEnd type="none" w="med" len="med"/>
+                      <a:tailEnd type="none" w="med" len="med"/>
+                    </a:lnB>
+                  </a:tcPr>
+                </a:tc>
+                <a:tc>
+                  <a:txBody>
+                    <a:bodyPr/>
+                    <a:lstStyle/>
                     <a:p>
                       <a:pPr algn="l" marL="152400" indent="-152400">
                         <a:spcAft>

</xml_diff>